<commit_message>
Revise slide content for mid-project review presentation
</commit_message>
<xml_diff>
--- a/Presentation/Retail Sales & Inventory Analytics Mid Review PPT.pptx
+++ b/Presentation/Retail Sales & Inventory Analytics Mid Review PPT.pptx
@@ -255,7 +255,7 @@
           <a:p>
             <a:fld id="{9E88B8F3-31C2-4698-B74C-D5D76CFD8ACD}" type="datetimeFigureOut">
               <a:rPr lang="ru-RU" smtClean="0"/>
-              <a:t>28.05.2026</a:t>
+              <a:t>30.05.2026</a:t>
             </a:fld>
             <a:endParaRPr lang="ru-RU" dirty="0"/>
           </a:p>
@@ -432,7 +432,7 @@
           <a:p>
             <a:fld id="{7000EB3D-2307-4317-8A1D-B47FA45245F0}" type="datetimeFigureOut">
               <a:rPr lang="ru-RU" smtClean="0"/>
-              <a:t>28.05.2026</a:t>
+              <a:t>30.05.2026</a:t>
             </a:fld>
             <a:endParaRPr lang="ru-RU" dirty="0"/>
           </a:p>
@@ -13891,26 +13891,27 @@
             <p:ph type="body" sz="quarter" idx="13"/>
           </p:nvPr>
         </p:nvSpPr>
-        <p:spPr/>
+        <p:spPr>
+          <a:xfrm>
+            <a:off x="770022" y="3773555"/>
+            <a:ext cx="9709720" cy="531716"/>
+          </a:xfrm>
+        </p:spPr>
         <p:txBody>
           <a:bodyPr/>
           <a:lstStyle/>
           <a:p>
             <a:r>
-              <a:rPr lang="en-US" dirty="0">
-                <a:solidFill>
-                  <a:schemeClr val="bg1">
-                    <a:lumMod val="75000"/>
-                  </a:schemeClr>
+              <a:rPr lang="en-US" b="1" dirty="0">
+                <a:solidFill>
+                  <a:schemeClr val="bg1"/>
                 </a:solidFill>
               </a:rPr>
               <a:t>Mid-Project Progress Review: Weeks 1 &amp; 2</a:t>
             </a:r>
-            <a:endParaRPr lang="ru-RU" dirty="0">
+            <a:endParaRPr lang="ru-RU" b="1" dirty="0">
               <a:solidFill>
-                <a:schemeClr val="bg1">
-                  <a:lumMod val="75000"/>
-                </a:schemeClr>
+                <a:schemeClr val="bg1"/>
               </a:solidFill>
             </a:endParaRPr>
           </a:p>
@@ -14001,7 +14002,7 @@
         <p:spPr>
           <a:xfrm>
             <a:off x="697579" y="5218902"/>
-            <a:ext cx="2457997" cy="1056391"/>
+            <a:ext cx="6348680" cy="1522557"/>
           </a:xfrm>
         </p:spPr>
         <p:txBody>
@@ -14016,8 +14017,144 @@
                   </a:schemeClr>
                 </a:solidFill>
               </a:rPr>
-              <a:t>On behalf of the Data Analytics Intern Team - 5</a:t>
-            </a:r>
+              <a:t>On behalf of the Data Analytics Intern Team – 5</a:t>
+            </a:r>
+            <a:br>
+              <a:rPr lang="en-US" dirty="0">
+                <a:solidFill>
+                  <a:schemeClr val="bg1">
+                    <a:lumMod val="75000"/>
+                  </a:schemeClr>
+                </a:solidFill>
+              </a:rPr>
+            </a:br>
+            <a:r>
+              <a:rPr lang="en-US" dirty="0">
+                <a:solidFill>
+                  <a:schemeClr val="bg1">
+                    <a:lumMod val="75000"/>
+                  </a:schemeClr>
+                </a:solidFill>
+              </a:rPr>
+              <a:t>- </a:t>
+            </a:r>
+            <a:r>
+              <a:rPr lang="en-US" dirty="0" err="1">
+                <a:solidFill>
+                  <a:schemeClr val="bg1">
+                    <a:lumMod val="75000"/>
+                  </a:schemeClr>
+                </a:solidFill>
+              </a:rPr>
+              <a:t>Kasak</a:t>
+            </a:r>
+            <a:r>
+              <a:rPr lang="en-US" dirty="0">
+                <a:solidFill>
+                  <a:schemeClr val="bg1">
+                    <a:lumMod val="75000"/>
+                  </a:schemeClr>
+                </a:solidFill>
+              </a:rPr>
+              <a:t> </a:t>
+            </a:r>
+            <a:r>
+              <a:rPr lang="en-US" dirty="0" err="1">
+                <a:solidFill>
+                  <a:schemeClr val="bg1">
+                    <a:lumMod val="75000"/>
+                  </a:schemeClr>
+                </a:solidFill>
+              </a:rPr>
+              <a:t>Siwal</a:t>
+            </a:r>
+            <a:br>
+              <a:rPr lang="en-US" dirty="0">
+                <a:solidFill>
+                  <a:schemeClr val="bg1">
+                    <a:lumMod val="75000"/>
+                  </a:schemeClr>
+                </a:solidFill>
+              </a:rPr>
+            </a:br>
+            <a:r>
+              <a:rPr lang="en-US" dirty="0">
+                <a:solidFill>
+                  <a:schemeClr val="bg1">
+                    <a:lumMod val="75000"/>
+                  </a:schemeClr>
+                </a:solidFill>
+              </a:rPr>
+              <a:t>- </a:t>
+            </a:r>
+            <a:r>
+              <a:rPr lang="en-US" dirty="0" err="1">
+                <a:solidFill>
+                  <a:schemeClr val="bg1">
+                    <a:lumMod val="75000"/>
+                  </a:schemeClr>
+                </a:solidFill>
+              </a:rPr>
+              <a:t>Ahamad</a:t>
+            </a:r>
+            <a:r>
+              <a:rPr lang="en-US" dirty="0">
+                <a:solidFill>
+                  <a:schemeClr val="bg1">
+                    <a:lumMod val="75000"/>
+                  </a:schemeClr>
+                </a:solidFill>
+              </a:rPr>
+              <a:t> Irfan </a:t>
+            </a:r>
+            <a:r>
+              <a:rPr lang="en-US" dirty="0" err="1">
+                <a:solidFill>
+                  <a:schemeClr val="bg1">
+                    <a:lumMod val="75000"/>
+                  </a:schemeClr>
+                </a:solidFill>
+              </a:rPr>
+              <a:t>Maideen</a:t>
+            </a:r>
+            <a:r>
+              <a:rPr lang="en-US" dirty="0">
+                <a:solidFill>
+                  <a:schemeClr val="bg1">
+                    <a:lumMod val="75000"/>
+                  </a:schemeClr>
+                </a:solidFill>
+              </a:rPr>
+              <a:t> Y </a:t>
+            </a:r>
+            <a:br>
+              <a:rPr lang="en-US" dirty="0">
+                <a:solidFill>
+                  <a:schemeClr val="bg1">
+                    <a:lumMod val="75000"/>
+                  </a:schemeClr>
+                </a:solidFill>
+              </a:rPr>
+            </a:br>
+            <a:r>
+              <a:rPr lang="en-US" dirty="0">
+                <a:solidFill>
+                  <a:schemeClr val="bg1">
+                    <a:lumMod val="75000"/>
+                  </a:schemeClr>
+                </a:solidFill>
+              </a:rPr>
+              <a:t>- Swetha Muthu </a:t>
+            </a:r>
+            <a:br>
+              <a:rPr lang="en-US" dirty="0">
+                <a:solidFill>
+                  <a:schemeClr val="bg1">
+                    <a:lumMod val="75000"/>
+                  </a:schemeClr>
+                </a:solidFill>
+              </a:rPr>
+            </a:br>
             <a:endParaRPr lang="ru-RU" dirty="0">
               <a:solidFill>
                 <a:schemeClr val="bg1">

</xml_diff>